<commit_message>
Connect history catalogue search and improve accessible web learning flows
</commit_message>
<xml_diff>
--- a/docs/CultureBridge_구현결과_발표_2026-10-23.pptx
+++ b/docs/CultureBridge_구현결과_발표_2026-10-23.pptx
@@ -2,22 +2,22 @@
 <file path=ppt/presentation.xml><?xml version="1.0" encoding="utf-8"?>
 <p:presentation xmlns:p="http://schemas.openxmlformats.org/presentationml/2006/main">
   <p:sldMasterIdLst>
-    <p:sldMasterId xmlns:r="http://schemas.openxmlformats.org/officeDocument/2006/relationships" id="2147483648" r:id="Rcf3533f8955e4f70"/>
+    <p:sldMasterId xmlns:r="http://schemas.openxmlformats.org/officeDocument/2006/relationships" id="2147483648" r:id="Rea4c172e14f440be"/>
   </p:sldMasterIdLst>
   <p:notesMasterIdLst>
-    <p:notesMasterId xmlns:r="http://schemas.openxmlformats.org/officeDocument/2006/relationships" r:id="R4114b06032564e18"/>
+    <p:notesMasterId xmlns:r="http://schemas.openxmlformats.org/officeDocument/2006/relationships" r:id="R76be9e396fd64790"/>
   </p:notesMasterIdLst>
   <p:sldIdLst>
-    <p:sldId xmlns:r="http://schemas.openxmlformats.org/officeDocument/2006/relationships" id="256" r:id="Redb2291b1653473b"/>
-    <p:sldId xmlns:r="http://schemas.openxmlformats.org/officeDocument/2006/relationships" id="257" r:id="R8278115d0cd14358"/>
-    <p:sldId xmlns:r="http://schemas.openxmlformats.org/officeDocument/2006/relationships" id="258" r:id="R019262499c7f45a3"/>
-    <p:sldId xmlns:r="http://schemas.openxmlformats.org/officeDocument/2006/relationships" id="259" r:id="R6eb79b6051484be2"/>
-    <p:sldId xmlns:r="http://schemas.openxmlformats.org/officeDocument/2006/relationships" id="260" r:id="R99ff8d5f47884fe0"/>
-    <p:sldId xmlns:r="http://schemas.openxmlformats.org/officeDocument/2006/relationships" id="261" r:id="Rc5bad35b51684a7e"/>
-    <p:sldId xmlns:r="http://schemas.openxmlformats.org/officeDocument/2006/relationships" id="262" r:id="R26798e1d3b5040df"/>
-    <p:sldId xmlns:r="http://schemas.openxmlformats.org/officeDocument/2006/relationships" id="263" r:id="Rf2aeba538d0a42b4"/>
-    <p:sldId xmlns:r="http://schemas.openxmlformats.org/officeDocument/2006/relationships" id="264" r:id="R7a234bbee65f4df6"/>
-    <p:sldId xmlns:r="http://schemas.openxmlformats.org/officeDocument/2006/relationships" id="265" r:id="R0bb81759920f4eda"/>
+    <p:sldId xmlns:r="http://schemas.openxmlformats.org/officeDocument/2006/relationships" id="256" r:id="R637a743c8c354f91"/>
+    <p:sldId xmlns:r="http://schemas.openxmlformats.org/officeDocument/2006/relationships" id="257" r:id="R47315b1e366d496c"/>
+    <p:sldId xmlns:r="http://schemas.openxmlformats.org/officeDocument/2006/relationships" id="258" r:id="R54857c7739054afc"/>
+    <p:sldId xmlns:r="http://schemas.openxmlformats.org/officeDocument/2006/relationships" id="259" r:id="R39d7e1654bb04444"/>
+    <p:sldId xmlns:r="http://schemas.openxmlformats.org/officeDocument/2006/relationships" id="260" r:id="Ra1dcad2603154a28"/>
+    <p:sldId xmlns:r="http://schemas.openxmlformats.org/officeDocument/2006/relationships" id="261" r:id="R41fdc8b4c27e45d8"/>
+    <p:sldId xmlns:r="http://schemas.openxmlformats.org/officeDocument/2006/relationships" id="262" r:id="Rf239c3ec1f594421"/>
+    <p:sldId xmlns:r="http://schemas.openxmlformats.org/officeDocument/2006/relationships" id="263" r:id="R7822af6c0bed42e6"/>
+    <p:sldId xmlns:r="http://schemas.openxmlformats.org/officeDocument/2006/relationships" id="264" r:id="Rb7e363100f704eeb"/>
+    <p:sldId xmlns:r="http://schemas.openxmlformats.org/officeDocument/2006/relationships" id="265" r:id="R43b29d4eafc04866"/>
   </p:sldIdLst>
   <p:sldSz cx="12192000" cy="6858000"/>
   <p:notesSz cx="6858000" cy="9144000"/>
@@ -731,7 +731,7 @@
           <a:lstStyle xmlns:a="http://schemas.openxmlformats.org/drawingml/2006/main"/>
           <a:p xmlns:a="http://schemas.openxmlformats.org/drawingml/2006/main">
             <a:r>
-              <a:t>구현: agents/learning.py 및 agent_discovery_service.py. 해외 검색 도구를 추가했으며 UNESCO 본문은 AI로 전송하지 않는다. 일반 역사 질문은 현재 공식 포털 안내 범위다.</a:t>
+              <a:t>구현: agents/learning.py 및 agent_discovery_service.py. 해외 검색과 신편 한국사 제목 검색 도구를 제공한다. 역사 검색은 제목과 공식 원문 링크이며 본문 AI 설명이 아니다. UNESCO 본문도 AI로 전송하지 않는다.</a:t>
             </a:r>
           </a:p>
         </p:txBody>
@@ -871,7 +871,7 @@
           <a:lstStyle xmlns:a="http://schemas.openxmlformats.org/drawingml/2006/main"/>
           <a:p xmlns:a="http://schemas.openxmlformats.org/drawingml/2006/main">
             <a:r>
-              <a:t>이미지: 직접 개발한 CultureBridge 설정 화면. outputs/unified-design-20261021/settings-page.png. 실제 기기 사용성 검증과는 별개다.</a:t>
+              <a:t>이미지: 직접 개발한 CultureBridge 설정 화면. outputs/unified-design-20261021/settings-page.png. 추가된 /history-search는 인물·사건 제목을 실제 검색한다. 본문 바로가기 첫 Tab 초점과 업데이트 확인 창 Tab·Escape 취소, 320px 화면의 가로 넘침을 확인했다. 실제 브라우저 확대·기기 사용성은 별도다.</a:t>
             </a:r>
           </a:p>
         </p:txBody>
@@ -941,7 +941,7 @@
           <a:lstStyle xmlns:a="http://schemas.openxmlformats.org/drawingml/2006/main"/>
           <a:p xmlns:a="http://schemas.openxmlformats.org/drawingml/2006/main">
             <a:r>
-              <a:t>근거: docs/44_WBS_잔여작업_실행근거.md. 합성 경로 검사는 실제 학생 수업이나 학습 효과의 검증이 아니다. Python 3.13 결과는 최종 보고서에 확정 후 추가한다.</a:t>
+              <a:t>근거: docs/44_WBS_잔여작업_실행근거.md 및 docs/47_검색_접근성_웹기능_정합성_점검.md. 합성 경로 검사는 실제 학생 수업이나 학습 효과의 검증이 아니다. JS 이벤트는 테스트 대역에서 검사했으며 실제 음성·휴대전화 설치와 구분한다.</a:t>
             </a:r>
           </a:p>
         </p:txBody>
@@ -1128,7 +1128,7 @@
           <p:cNvPr id="3" name="Title">
             <a:extLst xmlns:a="http://schemas.openxmlformats.org/drawingml/2006/main">
               <a:ext uri="{FF2B5EF4-FFF2-40B4-BE49-F238E27FC236}">
-                <a16:creationId xmlns:a16="http://schemas.microsoft.com/office/drawing/2014/main" id="{C52E2503-CBB2-4BFC-8A6C-FCB8EAAB8B70}"/>
+                <a16:creationId xmlns:a16="http://schemas.microsoft.com/office/drawing/2014/main" id="{CB5DBBA4-31B1-468E-942E-AD6C10A967C0}"/>
               </a:ext>
             </a:extLst>
           </p:cNvPr>
@@ -1285,7 +1285,7 @@
           <p:cNvPr id="2" name="Subtitle">
             <a:extLst xmlns:a="http://schemas.openxmlformats.org/drawingml/2006/main">
               <a:ext uri="{FF2B5EF4-FFF2-40B4-BE49-F238E27FC236}">
-                <a16:creationId xmlns:a16="http://schemas.microsoft.com/office/drawing/2014/main" id="{1026D934-5F77-4FCC-9ADC-A6A148568C6C}"/>
+                <a16:creationId xmlns:a16="http://schemas.microsoft.com/office/drawing/2014/main" id="{7B0101FB-CF66-4871-84B7-C7EE8B09E280}"/>
               </a:ext>
             </a:extLst>
           </p:cNvPr>
@@ -1459,7 +1459,7 @@
           <p:cNvPr id="2" name="Section title">
             <a:extLst xmlns:a="http://schemas.openxmlformats.org/drawingml/2006/main">
               <a:ext uri="{FF2B5EF4-FFF2-40B4-BE49-F238E27FC236}">
-                <a16:creationId xmlns:a16="http://schemas.microsoft.com/office/drawing/2014/main" id="{7BC0397C-262C-4218-B834-530FE98BCA2B}"/>
+                <a16:creationId xmlns:a16="http://schemas.microsoft.com/office/drawing/2014/main" id="{29E2DC86-762C-4DA3-8332-D960425863A8}"/>
               </a:ext>
             </a:extLst>
           </p:cNvPr>
@@ -1633,7 +1633,7 @@
           <p:cNvPr id="3" name="Title">
             <a:extLst xmlns:a="http://schemas.openxmlformats.org/drawingml/2006/main">
               <a:ext uri="{FF2B5EF4-FFF2-40B4-BE49-F238E27FC236}">
-                <a16:creationId xmlns:a16="http://schemas.microsoft.com/office/drawing/2014/main" id="{53DFD303-BAE4-4FE5-A172-CA774E745969}"/>
+                <a16:creationId xmlns:a16="http://schemas.microsoft.com/office/drawing/2014/main" id="{3A778130-F873-41FE-8F7D-CC7A2C8379C0}"/>
               </a:ext>
             </a:extLst>
           </p:cNvPr>
@@ -1790,7 +1790,7 @@
           <p:cNvPr id="2" name="Body">
             <a:extLst xmlns:a="http://schemas.openxmlformats.org/drawingml/2006/main">
               <a:ext uri="{FF2B5EF4-FFF2-40B4-BE49-F238E27FC236}">
-                <a16:creationId xmlns:a16="http://schemas.microsoft.com/office/drawing/2014/main" id="{099B0418-9367-4362-9F82-F28EEF82755D}"/>
+                <a16:creationId xmlns:a16="http://schemas.microsoft.com/office/drawing/2014/main" id="{473BFACA-B8FF-4D17-97F8-415BB10878CD}"/>
               </a:ext>
             </a:extLst>
           </p:cNvPr>
@@ -1964,7 +1964,7 @@
           <p:cNvPr id="4" name="Title">
             <a:extLst xmlns:a="http://schemas.openxmlformats.org/drawingml/2006/main">
               <a:ext uri="{FF2B5EF4-FFF2-40B4-BE49-F238E27FC236}">
-                <a16:creationId xmlns:a16="http://schemas.microsoft.com/office/drawing/2014/main" id="{04678ADD-3E25-4119-AF82-97A3DB9C5B49}"/>
+                <a16:creationId xmlns:a16="http://schemas.microsoft.com/office/drawing/2014/main" id="{2FA839E4-7964-4751-BF1D-F274C70C3320}"/>
               </a:ext>
             </a:extLst>
           </p:cNvPr>
@@ -2121,7 +2121,7 @@
           <p:cNvPr id="2" name="Left column">
             <a:extLst xmlns:a="http://schemas.openxmlformats.org/drawingml/2006/main">
               <a:ext uri="{FF2B5EF4-FFF2-40B4-BE49-F238E27FC236}">
-                <a16:creationId xmlns:a16="http://schemas.microsoft.com/office/drawing/2014/main" id="{8766BFBB-9C88-4DC7-B39F-946E57D68DC1}"/>
+                <a16:creationId xmlns:a16="http://schemas.microsoft.com/office/drawing/2014/main" id="{5B10B001-414C-47FB-ACE5-C063D591D52D}"/>
               </a:ext>
             </a:extLst>
           </p:cNvPr>
@@ -2278,7 +2278,7 @@
           <p:cNvPr id="3" name="Right column">
             <a:extLst xmlns:a="http://schemas.openxmlformats.org/drawingml/2006/main">
               <a:ext uri="{FF2B5EF4-FFF2-40B4-BE49-F238E27FC236}">
-                <a16:creationId xmlns:a16="http://schemas.microsoft.com/office/drawing/2014/main" id="{1BAD7152-18C5-4C13-AA59-D0C97419A2F3}"/>
+                <a16:creationId xmlns:a16="http://schemas.microsoft.com/office/drawing/2014/main" id="{E0B7E6BE-8848-46DC-B33C-BE0E3243B94B}"/>
               </a:ext>
             </a:extLst>
           </p:cNvPr>
@@ -2452,7 +2452,7 @@
           <p:cNvPr id="3" name="Title">
             <a:extLst xmlns:a="http://schemas.openxmlformats.org/drawingml/2006/main">
               <a:ext uri="{FF2B5EF4-FFF2-40B4-BE49-F238E27FC236}">
-                <a16:creationId xmlns:a16="http://schemas.microsoft.com/office/drawing/2014/main" id="{11AF8770-5ECD-4FE4-85B6-68ED1A65F4E3}"/>
+                <a16:creationId xmlns:a16="http://schemas.microsoft.com/office/drawing/2014/main" id="{C3C0F15A-7F28-4857-BBC7-174F642A7268}"/>
               </a:ext>
             </a:extLst>
           </p:cNvPr>
@@ -2609,7 +2609,7 @@
           <p:cNvPr id="2" name="Left column">
             <a:extLst xmlns:a="http://schemas.openxmlformats.org/drawingml/2006/main">
               <a:ext uri="{FF2B5EF4-FFF2-40B4-BE49-F238E27FC236}">
-                <a16:creationId xmlns:a16="http://schemas.microsoft.com/office/drawing/2014/main" id="{BFB91ECF-4B95-4A47-83D6-D594859E37AE}"/>
+                <a16:creationId xmlns:a16="http://schemas.microsoft.com/office/drawing/2014/main" id="{8073F0D5-47D2-4051-9B13-515C1471FE98}"/>
               </a:ext>
             </a:extLst>
           </p:cNvPr>
@@ -2804,12 +2804,12 @@
   </p:cSld>
   <p:clrMap bg1="lt1" tx1="dk1" bg2="lt2" tx2="dk2" accent1="accent1" accent2="accent2" accent3="accent3" accent4="accent4" accent5="accent5" accent6="accent6" hlink="hlink" folHlink="folHlink"/>
   <p:sldLayoutIdLst>
-    <p:sldLayoutId xmlns:r="http://schemas.openxmlformats.org/officeDocument/2006/relationships" id="2147483649" r:id="Ra898a2e65608447e"/>
-    <p:sldLayoutId xmlns:r="http://schemas.openxmlformats.org/officeDocument/2006/relationships" id="2147483650" r:id="Rbf9ceb8cdb2e41c3"/>
-    <p:sldLayoutId xmlns:r="http://schemas.openxmlformats.org/officeDocument/2006/relationships" id="2147483651" r:id="R40d0845dbbb9473f"/>
-    <p:sldLayoutId xmlns:r="http://schemas.openxmlformats.org/officeDocument/2006/relationships" id="2147483652" r:id="R59643a7f18fd43db"/>
-    <p:sldLayoutId xmlns:r="http://schemas.openxmlformats.org/officeDocument/2006/relationships" id="2147483653" r:id="R9214b66cafc944b9"/>
-    <p:sldLayoutId xmlns:r="http://schemas.openxmlformats.org/officeDocument/2006/relationships" id="2147483654" r:id="R730d6a745ce14940"/>
+    <p:sldLayoutId xmlns:r="http://schemas.openxmlformats.org/officeDocument/2006/relationships" id="2147483649" r:id="R668f941a383b4473"/>
+    <p:sldLayoutId xmlns:r="http://schemas.openxmlformats.org/officeDocument/2006/relationships" id="2147483650" r:id="Rdbae5e10c5d44ee9"/>
+    <p:sldLayoutId xmlns:r="http://schemas.openxmlformats.org/officeDocument/2006/relationships" id="2147483651" r:id="Rca100e41da2f43d2"/>
+    <p:sldLayoutId xmlns:r="http://schemas.openxmlformats.org/officeDocument/2006/relationships" id="2147483652" r:id="Rf395035f756b4740"/>
+    <p:sldLayoutId xmlns:r="http://schemas.openxmlformats.org/officeDocument/2006/relationships" id="2147483653" r:id="R5b9738c649ba46a3"/>
+    <p:sldLayoutId xmlns:r="http://schemas.openxmlformats.org/officeDocument/2006/relationships" id="2147483654" r:id="Rbb114d487b804d6c"/>
   </p:sldLayoutIdLst>
   <p:txStyles>
     <p:titleStyle>
@@ -3360,7 +3360,7 @@
           <p:cNvPr id="9" name="">
             <a:extLst xmlns:a="http://schemas.openxmlformats.org/drawingml/2006/main">
               <a:ext uri="{FF2B5EF4-FFF2-40B4-BE49-F238E27FC236}">
-                <a16:creationId xmlns:a16="http://schemas.microsoft.com/office/drawing/2014/main" id="{98754201-79F3-46E1-8850-1BE9E54ED39E}"/>
+                <a16:creationId xmlns:a16="http://schemas.microsoft.com/office/drawing/2014/main" id="{5348B43D-2C8E-4B16-AAAF-AA80536DF287}"/>
               </a:ext>
             </a:extLst>
           </p:cNvPr>
@@ -3429,7 +3429,7 @@
           <p:cNvPr id="2" name="">
             <a:extLst xmlns:a="http://schemas.openxmlformats.org/drawingml/2006/main">
               <a:ext uri="{FF2B5EF4-FFF2-40B4-BE49-F238E27FC236}">
-                <a16:creationId xmlns:a16="http://schemas.microsoft.com/office/drawing/2014/main" id="{83134D9C-619A-4B88-B1AC-55D61A86E525}"/>
+                <a16:creationId xmlns:a16="http://schemas.microsoft.com/office/drawing/2014/main" id="{64389CC6-86B3-40ED-8782-B7554A0253A5}"/>
               </a:ext>
             </a:extLst>
           </p:cNvPr>
@@ -3498,7 +3498,7 @@
           <p:cNvPr id="3" name="">
             <a:extLst xmlns:a="http://schemas.openxmlformats.org/drawingml/2006/main">
               <a:ext uri="{FF2B5EF4-FFF2-40B4-BE49-F238E27FC236}">
-                <a16:creationId xmlns:a16="http://schemas.microsoft.com/office/drawing/2014/main" id="{B3F08238-D0C9-4087-BE2B-ACED8BAB0B11}"/>
+                <a16:creationId xmlns:a16="http://schemas.microsoft.com/office/drawing/2014/main" id="{2EFF322C-E1F0-4B2E-B57C-2F1B75AF7446}"/>
               </a:ext>
             </a:extLst>
           </p:cNvPr>
@@ -3567,7 +3567,7 @@
           <p:cNvPr id="4" name="">
             <a:extLst xmlns:a="http://schemas.openxmlformats.org/drawingml/2006/main">
               <a:ext uri="{FF2B5EF4-FFF2-40B4-BE49-F238E27FC236}">
-                <a16:creationId xmlns:a16="http://schemas.microsoft.com/office/drawing/2014/main" id="{99C54536-2963-4419-971A-F3B793D1EF65}"/>
+                <a16:creationId xmlns:a16="http://schemas.microsoft.com/office/drawing/2014/main" id="{569044CB-4E0C-41B4-BA29-6552104557A8}"/>
               </a:ext>
             </a:extLst>
           </p:cNvPr>
@@ -3636,7 +3636,7 @@
           <p:cNvPr id="5" name="">
             <a:extLst xmlns:a="http://schemas.openxmlformats.org/drawingml/2006/main">
               <a:ext uri="{FF2B5EF4-FFF2-40B4-BE49-F238E27FC236}">
-                <a16:creationId xmlns:a16="http://schemas.microsoft.com/office/drawing/2014/main" id="{717DE25A-04AB-4EC2-8AAD-04368B364118}"/>
+                <a16:creationId xmlns:a16="http://schemas.microsoft.com/office/drawing/2014/main" id="{4FBE481C-9F00-449E-86CB-867F6FAA443F}"/>
               </a:ext>
             </a:extLst>
           </p:cNvPr>
@@ -3705,7 +3705,7 @@
           <p:cNvPr id="6" name="">
             <a:extLst xmlns:a="http://schemas.openxmlformats.org/drawingml/2006/main">
               <a:ext uri="{FF2B5EF4-FFF2-40B4-BE49-F238E27FC236}">
-                <a16:creationId xmlns:a16="http://schemas.microsoft.com/office/drawing/2014/main" id="{C5E4BF3B-1E3C-45FE-A051-D06AA382BC66}"/>
+                <a16:creationId xmlns:a16="http://schemas.microsoft.com/office/drawing/2014/main" id="{0A1A8E20-0E4A-4585-B33B-89462C82B2C1}"/>
               </a:ext>
             </a:extLst>
           </p:cNvPr>
@@ -3774,7 +3774,7 @@
           <p:cNvPr id="7" name="">
             <a:extLst xmlns:a="http://schemas.openxmlformats.org/drawingml/2006/main">
               <a:ext uri="{FF2B5EF4-FFF2-40B4-BE49-F238E27FC236}">
-                <a16:creationId xmlns:a16="http://schemas.microsoft.com/office/drawing/2014/main" id="{651A15A5-7CB6-4B6B-A58E-D44F3E0C58F7}"/>
+                <a16:creationId xmlns:a16="http://schemas.microsoft.com/office/drawing/2014/main" id="{C4CBA1FA-7588-45F6-9D1F-4AA4F4526718}"/>
               </a:ext>
             </a:extLst>
           </p:cNvPr>
@@ -3843,7 +3843,7 @@
           <p:cNvPr id="8" name="">
             <a:extLst xmlns:a="http://schemas.openxmlformats.org/drawingml/2006/main">
               <a:ext uri="{FF2B5EF4-FFF2-40B4-BE49-F238E27FC236}">
-                <a16:creationId xmlns:a16="http://schemas.microsoft.com/office/drawing/2014/main" id="{43359C35-737A-4398-805E-246EB77D90F6}"/>
+                <a16:creationId xmlns:a16="http://schemas.microsoft.com/office/drawing/2014/main" id="{F8F32816-66FC-4F74-BF56-E38E01FF7452}"/>
               </a:ext>
             </a:extLst>
           </p:cNvPr>
@@ -3910,7 +3910,7 @@
     </p:spTree>
     <p:extLst>
       <p:ext uri="{BB962C8B-B14F-4D97-AF65-F5344CB8AC3E}">
-        <p14:creationId xmlns:p14="http://schemas.microsoft.com/office/powerpoint/2010/main" val="2030237533"/>
+        <p14:creationId xmlns:p14="http://schemas.microsoft.com/office/powerpoint/2010/main" val="970797376"/>
       </p:ext>
     </p:extLst>
   </p:cSld>
@@ -3941,7 +3941,7 @@
           <p:cNvPr id="10" name="">
             <a:extLst xmlns:a="http://schemas.openxmlformats.org/drawingml/2006/main">
               <a:ext uri="{FF2B5EF4-FFF2-40B4-BE49-F238E27FC236}">
-                <a16:creationId xmlns:a16="http://schemas.microsoft.com/office/drawing/2014/main" id="{C0E0DB0E-D347-4220-9E70-4A5E1C28712E}"/>
+                <a16:creationId xmlns:a16="http://schemas.microsoft.com/office/drawing/2014/main" id="{D74F592E-1DEA-4449-9F96-0377D09936DB}"/>
               </a:ext>
             </a:extLst>
           </p:cNvPr>
@@ -4010,7 +4010,7 @@
           <p:cNvPr id="2" name="">
             <a:extLst xmlns:a="http://schemas.openxmlformats.org/drawingml/2006/main">
               <a:ext uri="{FF2B5EF4-FFF2-40B4-BE49-F238E27FC236}">
-                <a16:creationId xmlns:a16="http://schemas.microsoft.com/office/drawing/2014/main" id="{B51A1050-6B95-4FA7-B0D0-C3610BD46F3E}"/>
+                <a16:creationId xmlns:a16="http://schemas.microsoft.com/office/drawing/2014/main" id="{D5B7A031-6515-4C92-BC53-D8023D9587F6}"/>
               </a:ext>
             </a:extLst>
           </p:cNvPr>
@@ -4079,7 +4079,7 @@
           <p:cNvPr id="3" name="">
             <a:extLst xmlns:a="http://schemas.openxmlformats.org/drawingml/2006/main">
               <a:ext uri="{FF2B5EF4-FFF2-40B4-BE49-F238E27FC236}">
-                <a16:creationId xmlns:a16="http://schemas.microsoft.com/office/drawing/2014/main" id="{E3A1EC77-A831-48D3-86F7-A03E9F179B61}"/>
+                <a16:creationId xmlns:a16="http://schemas.microsoft.com/office/drawing/2014/main" id="{4F233113-DB61-4F26-8922-70351BC949A0}"/>
               </a:ext>
             </a:extLst>
           </p:cNvPr>
@@ -4148,7 +4148,7 @@
           <p:cNvPr id="4" name="">
             <a:extLst xmlns:a="http://schemas.openxmlformats.org/drawingml/2006/main">
               <a:ext uri="{FF2B5EF4-FFF2-40B4-BE49-F238E27FC236}">
-                <a16:creationId xmlns:a16="http://schemas.microsoft.com/office/drawing/2014/main" id="{B8813546-FAAB-4E75-B84F-5F62BFE90840}"/>
+                <a16:creationId xmlns:a16="http://schemas.microsoft.com/office/drawing/2014/main" id="{1C8C26F6-589A-47F1-AFC8-972B74B56984}"/>
               </a:ext>
             </a:extLst>
           </p:cNvPr>
@@ -4217,7 +4217,7 @@
           <p:cNvPr id="5" name="">
             <a:extLst xmlns:a="http://schemas.openxmlformats.org/drawingml/2006/main">
               <a:ext uri="{FF2B5EF4-FFF2-40B4-BE49-F238E27FC236}">
-                <a16:creationId xmlns:a16="http://schemas.microsoft.com/office/drawing/2014/main" id="{746D2F22-6BE0-4CC9-8433-42915BEEF9BD}"/>
+                <a16:creationId xmlns:a16="http://schemas.microsoft.com/office/drawing/2014/main" id="{5988D1BC-0D9E-4065-AF20-9DDE7E11CE82}"/>
               </a:ext>
             </a:extLst>
           </p:cNvPr>
@@ -4286,7 +4286,7 @@
           <p:cNvPr id="6" name="">
             <a:extLst xmlns:a="http://schemas.openxmlformats.org/drawingml/2006/main">
               <a:ext uri="{FF2B5EF4-FFF2-40B4-BE49-F238E27FC236}">
-                <a16:creationId xmlns:a16="http://schemas.microsoft.com/office/drawing/2014/main" id="{357D1C1B-0A7C-496F-8850-78B84228BD50}"/>
+                <a16:creationId xmlns:a16="http://schemas.microsoft.com/office/drawing/2014/main" id="{5A237B2E-135C-4ADF-AC7A-43F9A00CA442}"/>
               </a:ext>
             </a:extLst>
           </p:cNvPr>
@@ -4355,7 +4355,7 @@
           <p:cNvPr id="7" name="">
             <a:extLst xmlns:a="http://schemas.openxmlformats.org/drawingml/2006/main">
               <a:ext uri="{FF2B5EF4-FFF2-40B4-BE49-F238E27FC236}">
-                <a16:creationId xmlns:a16="http://schemas.microsoft.com/office/drawing/2014/main" id="{43B3B9DB-D234-4E93-AB44-91A6EBCDC05A}"/>
+                <a16:creationId xmlns:a16="http://schemas.microsoft.com/office/drawing/2014/main" id="{33AAB3A5-2FFD-470A-A6FA-7A63105CA3F6}"/>
               </a:ext>
             </a:extLst>
           </p:cNvPr>
@@ -4424,7 +4424,7 @@
           <p:cNvPr id="8" name="">
             <a:extLst xmlns:a="http://schemas.openxmlformats.org/drawingml/2006/main">
               <a:ext uri="{FF2B5EF4-FFF2-40B4-BE49-F238E27FC236}">
-                <a16:creationId xmlns:a16="http://schemas.microsoft.com/office/drawing/2014/main" id="{00FA1F4B-BAD4-4407-9386-8CAE54EB11D6}"/>
+                <a16:creationId xmlns:a16="http://schemas.microsoft.com/office/drawing/2014/main" id="{F16EC418-27CC-41EB-BACC-B02F5B1E21A9}"/>
               </a:ext>
             </a:extLst>
           </p:cNvPr>
@@ -4493,7 +4493,7 @@
           <p:cNvPr id="9" name="">
             <a:extLst xmlns:a="http://schemas.openxmlformats.org/drawingml/2006/main">
               <a:ext uri="{FF2B5EF4-FFF2-40B4-BE49-F238E27FC236}">
-                <a16:creationId xmlns:a16="http://schemas.microsoft.com/office/drawing/2014/main" id="{75EF27A7-5300-438F-90D9-DB131544BDB4}"/>
+                <a16:creationId xmlns:a16="http://schemas.microsoft.com/office/drawing/2014/main" id="{B4FF9623-250A-43C7-A21F-906774D992F9}"/>
               </a:ext>
             </a:extLst>
           </p:cNvPr>
@@ -4560,7 +4560,7 @@
     </p:spTree>
     <p:extLst>
       <p:ext uri="{BB962C8B-B14F-4D97-AF65-F5344CB8AC3E}">
-        <p14:creationId xmlns:p14="http://schemas.microsoft.com/office/powerpoint/2010/main" val="1519060210"/>
+        <p14:creationId xmlns:p14="http://schemas.microsoft.com/office/powerpoint/2010/main" val="1288314346"/>
       </p:ext>
     </p:extLst>
   </p:cSld>
@@ -4591,7 +4591,7 @@
           <p:cNvPr id="9" name="">
             <a:extLst xmlns:a="http://schemas.openxmlformats.org/drawingml/2006/main">
               <a:ext uri="{FF2B5EF4-FFF2-40B4-BE49-F238E27FC236}">
-                <a16:creationId xmlns:a16="http://schemas.microsoft.com/office/drawing/2014/main" id="{65FF3266-2298-446E-B532-4CB80D73BB04}"/>
+                <a16:creationId xmlns:a16="http://schemas.microsoft.com/office/drawing/2014/main" id="{9E2339D5-FB57-48AF-BAAB-38C7A59BCCCA}"/>
               </a:ext>
             </a:extLst>
           </p:cNvPr>
@@ -4660,7 +4660,7 @@
           <p:cNvPr id="2" name="">
             <a:extLst xmlns:a="http://schemas.openxmlformats.org/drawingml/2006/main">
               <a:ext uri="{FF2B5EF4-FFF2-40B4-BE49-F238E27FC236}">
-                <a16:creationId xmlns:a16="http://schemas.microsoft.com/office/drawing/2014/main" id="{AA2DCC99-3273-48E1-B2BF-D9076EFBA29A}"/>
+                <a16:creationId xmlns:a16="http://schemas.microsoft.com/office/drawing/2014/main" id="{C584D349-51C5-48B4-90E8-51F84A65B866}"/>
               </a:ext>
             </a:extLst>
           </p:cNvPr>
@@ -4729,7 +4729,7 @@
           <p:cNvPr id="3" name="">
             <a:extLst xmlns:a="http://schemas.openxmlformats.org/drawingml/2006/main">
               <a:ext uri="{FF2B5EF4-FFF2-40B4-BE49-F238E27FC236}">
-                <a16:creationId xmlns:a16="http://schemas.microsoft.com/office/drawing/2014/main" id="{56448DCD-5981-4664-8300-B9318E2B98F0}"/>
+                <a16:creationId xmlns:a16="http://schemas.microsoft.com/office/drawing/2014/main" id="{89016919-022E-4ECA-A05F-53474921D587}"/>
               </a:ext>
             </a:extLst>
           </p:cNvPr>
@@ -4798,7 +4798,7 @@
           <p:cNvPr id="4" name="">
             <a:extLst xmlns:a="http://schemas.openxmlformats.org/drawingml/2006/main">
               <a:ext uri="{FF2B5EF4-FFF2-40B4-BE49-F238E27FC236}">
-                <a16:creationId xmlns:a16="http://schemas.microsoft.com/office/drawing/2014/main" id="{86438C90-3428-4855-A82A-E65E75FCB9AC}"/>
+                <a16:creationId xmlns:a16="http://schemas.microsoft.com/office/drawing/2014/main" id="{D8313CA6-8933-4A20-8FD3-101E429D03F8}"/>
               </a:ext>
             </a:extLst>
           </p:cNvPr>
@@ -4867,7 +4867,7 @@
           <p:cNvPr id="5" name="">
             <a:extLst xmlns:a="http://schemas.openxmlformats.org/drawingml/2006/main">
               <a:ext uri="{FF2B5EF4-FFF2-40B4-BE49-F238E27FC236}">
-                <a16:creationId xmlns:a16="http://schemas.microsoft.com/office/drawing/2014/main" id="{A51286E0-695A-4449-880F-F0337D6762A6}"/>
+                <a16:creationId xmlns:a16="http://schemas.microsoft.com/office/drawing/2014/main" id="{DDC43B8A-0385-46F8-BD2D-15F79B59864B}"/>
               </a:ext>
             </a:extLst>
           </p:cNvPr>
@@ -4936,7 +4936,7 @@
           <p:cNvPr id="6" name="">
             <a:extLst xmlns:a="http://schemas.openxmlformats.org/drawingml/2006/main">
               <a:ext uri="{FF2B5EF4-FFF2-40B4-BE49-F238E27FC236}">
-                <a16:creationId xmlns:a16="http://schemas.microsoft.com/office/drawing/2014/main" id="{49C3064A-076B-4FC6-BDC8-CCD5D1FC15C9}"/>
+                <a16:creationId xmlns:a16="http://schemas.microsoft.com/office/drawing/2014/main" id="{105E0F82-021E-4517-94C8-B524BEC967BC}"/>
               </a:ext>
             </a:extLst>
           </p:cNvPr>
@@ -5005,7 +5005,7 @@
           <p:cNvPr id="7" name="">
             <a:extLst xmlns:a="http://schemas.openxmlformats.org/drawingml/2006/main">
               <a:ext uri="{FF2B5EF4-FFF2-40B4-BE49-F238E27FC236}">
-                <a16:creationId xmlns:a16="http://schemas.microsoft.com/office/drawing/2014/main" id="{87801446-B71A-469A-A596-5AAB2BF66B3E}"/>
+                <a16:creationId xmlns:a16="http://schemas.microsoft.com/office/drawing/2014/main" id="{D4F21CED-3E07-4096-A9FC-F0C6C7A1FFA5}"/>
               </a:ext>
             </a:extLst>
           </p:cNvPr>
@@ -5074,7 +5074,7 @@
           <p:cNvPr id="8" name="">
             <a:extLst xmlns:a="http://schemas.openxmlformats.org/drawingml/2006/main">
               <a:ext uri="{FF2B5EF4-FFF2-40B4-BE49-F238E27FC236}">
-                <a16:creationId xmlns:a16="http://schemas.microsoft.com/office/drawing/2014/main" id="{00A7CD00-F517-4B48-8A9D-536EEF1CD2D5}"/>
+                <a16:creationId xmlns:a16="http://schemas.microsoft.com/office/drawing/2014/main" id="{4CAD9EBE-3752-4F7F-B15F-5CF150DB6F66}"/>
               </a:ext>
             </a:extLst>
           </p:cNvPr>
@@ -5141,7 +5141,7 @@
     </p:spTree>
     <p:extLst>
       <p:ext uri="{BB962C8B-B14F-4D97-AF65-F5344CB8AC3E}">
-        <p14:creationId xmlns:p14="http://schemas.microsoft.com/office/powerpoint/2010/main" val="1759176458"/>
+        <p14:creationId xmlns:p14="http://schemas.microsoft.com/office/powerpoint/2010/main" val="2129474686"/>
       </p:ext>
     </p:extLst>
   </p:cSld>
@@ -5172,7 +5172,7 @@
           <p:cNvPr id="10" name="">
             <a:extLst xmlns:a="http://schemas.openxmlformats.org/drawingml/2006/main">
               <a:ext uri="{FF2B5EF4-FFF2-40B4-BE49-F238E27FC236}">
-                <a16:creationId xmlns:a16="http://schemas.microsoft.com/office/drawing/2014/main" id="{1BD30FE6-0816-4D48-8E5C-5E92F673DA80}"/>
+                <a16:creationId xmlns:a16="http://schemas.microsoft.com/office/drawing/2014/main" id="{7CCBEEC5-9797-4210-9B64-8A860B5647B4}"/>
               </a:ext>
             </a:extLst>
           </p:cNvPr>
@@ -5241,7 +5241,7 @@
           <p:cNvPr id="2" name="">
             <a:extLst xmlns:a="http://schemas.openxmlformats.org/drawingml/2006/main">
               <a:ext uri="{FF2B5EF4-FFF2-40B4-BE49-F238E27FC236}">
-                <a16:creationId xmlns:a16="http://schemas.microsoft.com/office/drawing/2014/main" id="{31313592-FC02-453F-96DF-82ADF428873E}"/>
+                <a16:creationId xmlns:a16="http://schemas.microsoft.com/office/drawing/2014/main" id="{272F6128-3E1F-4CA1-A2E4-B11C3C647A2B}"/>
               </a:ext>
             </a:extLst>
           </p:cNvPr>
@@ -5310,7 +5310,7 @@
           <p:cNvPr id="3" name="">
             <a:extLst xmlns:a="http://schemas.openxmlformats.org/drawingml/2006/main">
               <a:ext uri="{FF2B5EF4-FFF2-40B4-BE49-F238E27FC236}">
-                <a16:creationId xmlns:a16="http://schemas.microsoft.com/office/drawing/2014/main" id="{06BA3E53-3C0F-410C-B072-2B7093D4D3A6}"/>
+                <a16:creationId xmlns:a16="http://schemas.microsoft.com/office/drawing/2014/main" id="{E748849B-CA70-42C6-AC7E-252C25562D14}"/>
               </a:ext>
             </a:extLst>
           </p:cNvPr>
@@ -5379,7 +5379,7 @@
           <p:cNvPr id="4" name="">
             <a:extLst xmlns:a="http://schemas.openxmlformats.org/drawingml/2006/main">
               <a:ext uri="{FF2B5EF4-FFF2-40B4-BE49-F238E27FC236}">
-                <a16:creationId xmlns:a16="http://schemas.microsoft.com/office/drawing/2014/main" id="{6BA2A76F-C97E-4369-9B4A-E130F3A2A0AD}"/>
+                <a16:creationId xmlns:a16="http://schemas.microsoft.com/office/drawing/2014/main" id="{9F9B6C0D-0109-4E86-8F76-0B14467A5368}"/>
               </a:ext>
             </a:extLst>
           </p:cNvPr>
@@ -5448,7 +5448,7 @@
           <p:cNvPr id="5" name="">
             <a:extLst xmlns:a="http://schemas.openxmlformats.org/drawingml/2006/main">
               <a:ext uri="{FF2B5EF4-FFF2-40B4-BE49-F238E27FC236}">
-                <a16:creationId xmlns:a16="http://schemas.microsoft.com/office/drawing/2014/main" id="{07D81CB6-9B9A-4A9C-96A2-D2128BF81E21}"/>
+                <a16:creationId xmlns:a16="http://schemas.microsoft.com/office/drawing/2014/main" id="{A1C3E7BC-386C-4B5F-A58F-509E32E471ED}"/>
               </a:ext>
             </a:extLst>
           </p:cNvPr>
@@ -5517,7 +5517,7 @@
           <p:cNvPr id="6" name="">
             <a:extLst xmlns:a="http://schemas.openxmlformats.org/drawingml/2006/main">
               <a:ext uri="{FF2B5EF4-FFF2-40B4-BE49-F238E27FC236}">
-                <a16:creationId xmlns:a16="http://schemas.microsoft.com/office/drawing/2014/main" id="{DD5FAB65-5464-474E-8113-65475A547AC7}"/>
+                <a16:creationId xmlns:a16="http://schemas.microsoft.com/office/drawing/2014/main" id="{76B83C9C-22BA-4FA5-A4B9-15F7839F8D53}"/>
               </a:ext>
             </a:extLst>
           </p:cNvPr>
@@ -5586,7 +5586,7 @@
           <p:cNvPr id="7" name="">
             <a:extLst xmlns:a="http://schemas.openxmlformats.org/drawingml/2006/main">
               <a:ext uri="{FF2B5EF4-FFF2-40B4-BE49-F238E27FC236}">
-                <a16:creationId xmlns:a16="http://schemas.microsoft.com/office/drawing/2014/main" id="{637C5D10-0166-4EEC-B6B0-B0F2C375777D}"/>
+                <a16:creationId xmlns:a16="http://schemas.microsoft.com/office/drawing/2014/main" id="{0EDDE8D4-7ECC-46E7-9AFA-67C976E59229}"/>
               </a:ext>
             </a:extLst>
           </p:cNvPr>
@@ -5655,7 +5655,7 @@
           <p:cNvPr id="8" name="">
             <a:extLst xmlns:a="http://schemas.openxmlformats.org/drawingml/2006/main">
               <a:ext uri="{FF2B5EF4-FFF2-40B4-BE49-F238E27FC236}">
-                <a16:creationId xmlns:a16="http://schemas.microsoft.com/office/drawing/2014/main" id="{880A884A-B820-422A-B51E-3C68B79B73A6}"/>
+                <a16:creationId xmlns:a16="http://schemas.microsoft.com/office/drawing/2014/main" id="{E38EE366-F7F3-4575-BE9E-1DD415CD4BE9}"/>
               </a:ext>
             </a:extLst>
           </p:cNvPr>
@@ -5724,7 +5724,7 @@
           <p:cNvPr id="9" name="">
             <a:extLst xmlns:a="http://schemas.openxmlformats.org/drawingml/2006/main">
               <a:ext uri="{FF2B5EF4-FFF2-40B4-BE49-F238E27FC236}">
-                <a16:creationId xmlns:a16="http://schemas.microsoft.com/office/drawing/2014/main" id="{86AAFBF5-AADB-4BD7-BCC6-31F755F4E0EA}"/>
+                <a16:creationId xmlns:a16="http://schemas.microsoft.com/office/drawing/2014/main" id="{7B1000AF-43D7-4103-9456-145E81224347}"/>
               </a:ext>
             </a:extLst>
           </p:cNvPr>
@@ -5791,7 +5791,7 @@
     </p:spTree>
     <p:extLst>
       <p:ext uri="{BB962C8B-B14F-4D97-AF65-F5344CB8AC3E}">
-        <p14:creationId xmlns:p14="http://schemas.microsoft.com/office/powerpoint/2010/main" val="524944924"/>
+        <p14:creationId xmlns:p14="http://schemas.microsoft.com/office/powerpoint/2010/main" val="161005469"/>
       </p:ext>
     </p:extLst>
   </p:cSld>
@@ -5822,7 +5822,7 @@
           <p:cNvPr id="10" name="">
             <a:extLst xmlns:a="http://schemas.openxmlformats.org/drawingml/2006/main">
               <a:ext uri="{FF2B5EF4-FFF2-40B4-BE49-F238E27FC236}">
-                <a16:creationId xmlns:a16="http://schemas.microsoft.com/office/drawing/2014/main" id="{56FD5055-4431-4777-92D7-5307935ECE0E}"/>
+                <a16:creationId xmlns:a16="http://schemas.microsoft.com/office/drawing/2014/main" id="{C74F139C-33F9-4705-888E-3B2E3C93CA0C}"/>
               </a:ext>
             </a:extLst>
           </p:cNvPr>
@@ -5891,7 +5891,7 @@
           <p:cNvPr id="2" name="">
             <a:extLst xmlns:a="http://schemas.openxmlformats.org/drawingml/2006/main">
               <a:ext uri="{FF2B5EF4-FFF2-40B4-BE49-F238E27FC236}">
-                <a16:creationId xmlns:a16="http://schemas.microsoft.com/office/drawing/2014/main" id="{9AE6E3BE-4C01-4490-86A9-826F4E2B8D44}"/>
+                <a16:creationId xmlns:a16="http://schemas.microsoft.com/office/drawing/2014/main" id="{934716BE-6679-4AB6-82C7-31AE90DE19EB}"/>
               </a:ext>
             </a:extLst>
           </p:cNvPr>
@@ -5960,7 +5960,7 @@
           <p:cNvPr id="3" name="">
             <a:extLst xmlns:a="http://schemas.openxmlformats.org/drawingml/2006/main">
               <a:ext uri="{FF2B5EF4-FFF2-40B4-BE49-F238E27FC236}">
-                <a16:creationId xmlns:a16="http://schemas.microsoft.com/office/drawing/2014/main" id="{9728ADCF-092F-45A6-84D4-DED942854739}"/>
+                <a16:creationId xmlns:a16="http://schemas.microsoft.com/office/drawing/2014/main" id="{8B0FDB1D-7622-4719-BD05-223914FF65DE}"/>
               </a:ext>
             </a:extLst>
           </p:cNvPr>
@@ -6029,7 +6029,7 @@
           <p:cNvPr id="4" name="">
             <a:extLst xmlns:a="http://schemas.openxmlformats.org/drawingml/2006/main">
               <a:ext uri="{FF2B5EF4-FFF2-40B4-BE49-F238E27FC236}">
-                <a16:creationId xmlns:a16="http://schemas.microsoft.com/office/drawing/2014/main" id="{863ED09A-C3D3-458A-89A6-D16842906D74}"/>
+                <a16:creationId xmlns:a16="http://schemas.microsoft.com/office/drawing/2014/main" id="{D410356F-AE35-4E4C-8F7C-4AD73DDAFAC2}"/>
               </a:ext>
             </a:extLst>
           </p:cNvPr>
@@ -6098,7 +6098,7 @@
           <p:cNvPr id="5" name="">
             <a:extLst xmlns:a="http://schemas.openxmlformats.org/drawingml/2006/main">
               <a:ext uri="{FF2B5EF4-FFF2-40B4-BE49-F238E27FC236}">
-                <a16:creationId xmlns:a16="http://schemas.microsoft.com/office/drawing/2014/main" id="{17054C76-62C7-44A5-B67C-043FCE160191}"/>
+                <a16:creationId xmlns:a16="http://schemas.microsoft.com/office/drawing/2014/main" id="{EC3889B3-2A13-4676-AA9D-17EB7BD89497}"/>
               </a:ext>
             </a:extLst>
           </p:cNvPr>
@@ -6167,7 +6167,7 @@
           <p:cNvPr id="6" name="">
             <a:extLst xmlns:a="http://schemas.openxmlformats.org/drawingml/2006/main">
               <a:ext uri="{FF2B5EF4-FFF2-40B4-BE49-F238E27FC236}">
-                <a16:creationId xmlns:a16="http://schemas.microsoft.com/office/drawing/2014/main" id="{054BE02A-3426-4A91-9834-AAC6001CEE6B}"/>
+                <a16:creationId xmlns:a16="http://schemas.microsoft.com/office/drawing/2014/main" id="{A35FFC8C-890F-4D81-A525-2F53225927AF}"/>
               </a:ext>
             </a:extLst>
           </p:cNvPr>
@@ -6236,7 +6236,7 @@
           <p:cNvPr id="7" name="">
             <a:extLst xmlns:a="http://schemas.openxmlformats.org/drawingml/2006/main">
               <a:ext uri="{FF2B5EF4-FFF2-40B4-BE49-F238E27FC236}">
-                <a16:creationId xmlns:a16="http://schemas.microsoft.com/office/drawing/2014/main" id="{1E7A2174-7E6F-4754-A1A7-E9DD259C8D55}"/>
+                <a16:creationId xmlns:a16="http://schemas.microsoft.com/office/drawing/2014/main" id="{B6C6849F-C3FB-4EA2-B4FA-E8F3659ED8F8}"/>
               </a:ext>
             </a:extLst>
           </p:cNvPr>
@@ -6305,7 +6305,7 @@
           <p:cNvPr id="8" name="">
             <a:extLst xmlns:a="http://schemas.openxmlformats.org/drawingml/2006/main">
               <a:ext uri="{FF2B5EF4-FFF2-40B4-BE49-F238E27FC236}">
-                <a16:creationId xmlns:a16="http://schemas.microsoft.com/office/drawing/2014/main" id="{04A7F751-B81F-4914-88C6-BFDDA0080C51}"/>
+                <a16:creationId xmlns:a16="http://schemas.microsoft.com/office/drawing/2014/main" id="{BD9820BA-9106-4575-9C9E-CCD63E3E30AE}"/>
               </a:ext>
             </a:extLst>
           </p:cNvPr>
@@ -6374,7 +6374,7 @@
           <p:cNvPr id="9" name="">
             <a:extLst xmlns:a="http://schemas.openxmlformats.org/drawingml/2006/main">
               <a:ext uri="{FF2B5EF4-FFF2-40B4-BE49-F238E27FC236}">
-                <a16:creationId xmlns:a16="http://schemas.microsoft.com/office/drawing/2014/main" id="{C7AD33FB-658D-495D-B95E-2BE41E8216BC}"/>
+                <a16:creationId xmlns:a16="http://schemas.microsoft.com/office/drawing/2014/main" id="{E4A56D2B-F8D7-4DB2-ACB3-2353EEA28A2A}"/>
               </a:ext>
             </a:extLst>
           </p:cNvPr>
@@ -6441,7 +6441,7 @@
     </p:spTree>
     <p:extLst>
       <p:ext uri="{BB962C8B-B14F-4D97-AF65-F5344CB8AC3E}">
-        <p14:creationId xmlns:p14="http://schemas.microsoft.com/office/powerpoint/2010/main" val="1930617864"/>
+        <p14:creationId xmlns:p14="http://schemas.microsoft.com/office/powerpoint/2010/main" val="1757402942"/>
       </p:ext>
     </p:extLst>
   </p:cSld>
@@ -6472,7 +6472,7 @@
           <p:cNvPr id="10" name="">
             <a:extLst xmlns:a="http://schemas.openxmlformats.org/drawingml/2006/main">
               <a:ext uri="{FF2B5EF4-FFF2-40B4-BE49-F238E27FC236}">
-                <a16:creationId xmlns:a16="http://schemas.microsoft.com/office/drawing/2014/main" id="{6F0F8824-8C11-478B-BE2F-09B5340A045B}"/>
+                <a16:creationId xmlns:a16="http://schemas.microsoft.com/office/drawing/2014/main" id="{8A6D7F05-F818-4BD8-A5FD-6D15BE8DF909}"/>
               </a:ext>
             </a:extLst>
           </p:cNvPr>
@@ -6541,7 +6541,7 @@
           <p:cNvPr id="2" name="">
             <a:extLst xmlns:a="http://schemas.openxmlformats.org/drawingml/2006/main">
               <a:ext uri="{FF2B5EF4-FFF2-40B4-BE49-F238E27FC236}">
-                <a16:creationId xmlns:a16="http://schemas.microsoft.com/office/drawing/2014/main" id="{77AC27C8-1E2C-4872-992C-D1322F0FBA70}"/>
+                <a16:creationId xmlns:a16="http://schemas.microsoft.com/office/drawing/2014/main" id="{06175F51-7EF0-4FFD-8BF0-D93E3353DB03}"/>
               </a:ext>
             </a:extLst>
           </p:cNvPr>
@@ -6610,7 +6610,7 @@
           <p:cNvPr id="3" name="">
             <a:extLst xmlns:a="http://schemas.openxmlformats.org/drawingml/2006/main">
               <a:ext uri="{FF2B5EF4-FFF2-40B4-BE49-F238E27FC236}">
-                <a16:creationId xmlns:a16="http://schemas.microsoft.com/office/drawing/2014/main" id="{B366DB13-ADA1-4E24-8864-5C71708C6E6F}"/>
+                <a16:creationId xmlns:a16="http://schemas.microsoft.com/office/drawing/2014/main" id="{C55721F5-44A5-48D0-9963-F5D7CC9EEC91}"/>
               </a:ext>
             </a:extLst>
           </p:cNvPr>
@@ -6679,7 +6679,7 @@
           <p:cNvPr id="4" name="">
             <a:extLst xmlns:a="http://schemas.openxmlformats.org/drawingml/2006/main">
               <a:ext uri="{FF2B5EF4-FFF2-40B4-BE49-F238E27FC236}">
-                <a16:creationId xmlns:a16="http://schemas.microsoft.com/office/drawing/2014/main" id="{F5C7A7C2-D153-4B99-B25B-A49F13BD0C9C}"/>
+                <a16:creationId xmlns:a16="http://schemas.microsoft.com/office/drawing/2014/main" id="{9C6368BD-F2A7-4794-A1AD-7F25E1DB4A3A}"/>
               </a:ext>
             </a:extLst>
           </p:cNvPr>
@@ -6748,7 +6748,7 @@
           <p:cNvPr id="5" name="">
             <a:extLst xmlns:a="http://schemas.openxmlformats.org/drawingml/2006/main">
               <a:ext uri="{FF2B5EF4-FFF2-40B4-BE49-F238E27FC236}">
-                <a16:creationId xmlns:a16="http://schemas.microsoft.com/office/drawing/2014/main" id="{7E24C211-719A-49BA-B1F9-AD80988B022C}"/>
+                <a16:creationId xmlns:a16="http://schemas.microsoft.com/office/drawing/2014/main" id="{26E5457A-3FFE-4C40-8FCB-8D4AB04BCBC3}"/>
               </a:ext>
             </a:extLst>
           </p:cNvPr>
@@ -6817,7 +6817,7 @@
           <p:cNvPr id="6" name="">
             <a:extLst xmlns:a="http://schemas.openxmlformats.org/drawingml/2006/main">
               <a:ext uri="{FF2B5EF4-FFF2-40B4-BE49-F238E27FC236}">
-                <a16:creationId xmlns:a16="http://schemas.microsoft.com/office/drawing/2014/main" id="{811F3A29-6E87-429E-AB8D-34145FC37C99}"/>
+                <a16:creationId xmlns:a16="http://schemas.microsoft.com/office/drawing/2014/main" id="{B0F1DF6C-D7D0-4921-892A-19F2779DA60B}"/>
               </a:ext>
             </a:extLst>
           </p:cNvPr>
@@ -6886,7 +6886,7 @@
           <p:cNvPr id="7" name="">
             <a:extLst xmlns:a="http://schemas.openxmlformats.org/drawingml/2006/main">
               <a:ext uri="{FF2B5EF4-FFF2-40B4-BE49-F238E27FC236}">
-                <a16:creationId xmlns:a16="http://schemas.microsoft.com/office/drawing/2014/main" id="{A59CF4D5-DAAE-4867-832F-540186C8BE26}"/>
+                <a16:creationId xmlns:a16="http://schemas.microsoft.com/office/drawing/2014/main" id="{3B9C63EA-861C-4766-930A-81CB44BF7EDC}"/>
               </a:ext>
             </a:extLst>
           </p:cNvPr>
@@ -6955,7 +6955,7 @@
           <p:cNvPr id="8" name="">
             <a:extLst xmlns:a="http://schemas.openxmlformats.org/drawingml/2006/main">
               <a:ext uri="{FF2B5EF4-FFF2-40B4-BE49-F238E27FC236}">
-                <a16:creationId xmlns:a16="http://schemas.microsoft.com/office/drawing/2014/main" id="{0322E47A-A5E7-450D-AA19-A4E8589EC1DD}"/>
+                <a16:creationId xmlns:a16="http://schemas.microsoft.com/office/drawing/2014/main" id="{D17AAC72-6BE3-41C7-BEFB-9E5A12983493}"/>
               </a:ext>
             </a:extLst>
           </p:cNvPr>
@@ -7024,7 +7024,7 @@
           <p:cNvPr id="9" name="">
             <a:extLst xmlns:a="http://schemas.openxmlformats.org/drawingml/2006/main">
               <a:ext uri="{FF2B5EF4-FFF2-40B4-BE49-F238E27FC236}">
-                <a16:creationId xmlns:a16="http://schemas.microsoft.com/office/drawing/2014/main" id="{0501AF59-1B78-4881-B3FA-955D83DC965E}"/>
+                <a16:creationId xmlns:a16="http://schemas.microsoft.com/office/drawing/2014/main" id="{D920CFE0-50F5-4FAE-AA2C-4F3BBCFDA7F1}"/>
               </a:ext>
             </a:extLst>
           </p:cNvPr>
@@ -7091,7 +7091,7 @@
     </p:spTree>
     <p:extLst>
       <p:ext uri="{BB962C8B-B14F-4D97-AF65-F5344CB8AC3E}">
-        <p14:creationId xmlns:p14="http://schemas.microsoft.com/office/powerpoint/2010/main" val="405996008"/>
+        <p14:creationId xmlns:p14="http://schemas.microsoft.com/office/powerpoint/2010/main" val="1334908508"/>
       </p:ext>
     </p:extLst>
   </p:cSld>
@@ -7122,7 +7122,7 @@
           <p:cNvPr id="10" name="">
             <a:extLst xmlns:a="http://schemas.openxmlformats.org/drawingml/2006/main">
               <a:ext uri="{FF2B5EF4-FFF2-40B4-BE49-F238E27FC236}">
-                <a16:creationId xmlns:a16="http://schemas.microsoft.com/office/drawing/2014/main" id="{03F74456-0066-4DA4-8B37-253616ED04F8}"/>
+                <a16:creationId xmlns:a16="http://schemas.microsoft.com/office/drawing/2014/main" id="{16F61102-5F46-4FC8-B2D8-AFBBDF0D9D39}"/>
               </a:ext>
             </a:extLst>
           </p:cNvPr>
@@ -7191,7 +7191,7 @@
           <p:cNvPr id="2" name="">
             <a:extLst xmlns:a="http://schemas.openxmlformats.org/drawingml/2006/main">
               <a:ext uri="{FF2B5EF4-FFF2-40B4-BE49-F238E27FC236}">
-                <a16:creationId xmlns:a16="http://schemas.microsoft.com/office/drawing/2014/main" id="{4DA1BEA9-D42D-425B-BB9C-2FE53E66B658}"/>
+                <a16:creationId xmlns:a16="http://schemas.microsoft.com/office/drawing/2014/main" id="{DA1F73D6-E9DE-49C8-AF38-BE9B837B646C}"/>
               </a:ext>
             </a:extLst>
           </p:cNvPr>
@@ -7260,7 +7260,7 @@
           <p:cNvPr id="3" name="">
             <a:extLst xmlns:a="http://schemas.openxmlformats.org/drawingml/2006/main">
               <a:ext uri="{FF2B5EF4-FFF2-40B4-BE49-F238E27FC236}">
-                <a16:creationId xmlns:a16="http://schemas.microsoft.com/office/drawing/2014/main" id="{1AC66897-11B8-4BE5-8CCF-430BD2EC211C}"/>
+                <a16:creationId xmlns:a16="http://schemas.microsoft.com/office/drawing/2014/main" id="{8890ECDD-E3B2-495C-AF50-7E98C5C26388}"/>
               </a:ext>
             </a:extLst>
           </p:cNvPr>
@@ -7329,7 +7329,7 @@
           <p:cNvPr id="4" name="">
             <a:extLst xmlns:a="http://schemas.openxmlformats.org/drawingml/2006/main">
               <a:ext uri="{FF2B5EF4-FFF2-40B4-BE49-F238E27FC236}">
-                <a16:creationId xmlns:a16="http://schemas.microsoft.com/office/drawing/2014/main" id="{2C307B8D-E8EC-429F-A2FD-F720505E7635}"/>
+                <a16:creationId xmlns:a16="http://schemas.microsoft.com/office/drawing/2014/main" id="{11C66540-12D8-4BA8-8D7A-2DCFB862DCCB}"/>
               </a:ext>
             </a:extLst>
           </p:cNvPr>
@@ -7398,7 +7398,7 @@
           <p:cNvPr id="5" name="">
             <a:extLst xmlns:a="http://schemas.openxmlformats.org/drawingml/2006/main">
               <a:ext uri="{FF2B5EF4-FFF2-40B4-BE49-F238E27FC236}">
-                <a16:creationId xmlns:a16="http://schemas.microsoft.com/office/drawing/2014/main" id="{F66266B1-1C1A-48BD-8EF7-40ECAFCE32D7}"/>
+                <a16:creationId xmlns:a16="http://schemas.microsoft.com/office/drawing/2014/main" id="{EC6ADD20-27B5-4FCE-922B-CD51D185AFD8}"/>
               </a:ext>
             </a:extLst>
           </p:cNvPr>
@@ -7467,7 +7467,7 @@
           <p:cNvPr id="6" name="">
             <a:extLst xmlns:a="http://schemas.openxmlformats.org/drawingml/2006/main">
               <a:ext uri="{FF2B5EF4-FFF2-40B4-BE49-F238E27FC236}">
-                <a16:creationId xmlns:a16="http://schemas.microsoft.com/office/drawing/2014/main" id="{D64609B3-D522-48D7-9EA2-41C8598F6F63}"/>
+                <a16:creationId xmlns:a16="http://schemas.microsoft.com/office/drawing/2014/main" id="{817290A7-6146-48D7-9EFE-BAA3D2677C44}"/>
               </a:ext>
             </a:extLst>
           </p:cNvPr>
@@ -7536,7 +7536,7 @@
           <p:cNvPr id="7" name="">
             <a:extLst xmlns:a="http://schemas.openxmlformats.org/drawingml/2006/main">
               <a:ext uri="{FF2B5EF4-FFF2-40B4-BE49-F238E27FC236}">
-                <a16:creationId xmlns:a16="http://schemas.microsoft.com/office/drawing/2014/main" id="{44245A4E-FAA2-4E6A-8545-CE2C4477DE70}"/>
+                <a16:creationId xmlns:a16="http://schemas.microsoft.com/office/drawing/2014/main" id="{D188A40D-E30F-4264-B2D1-40BFE2947C74}"/>
               </a:ext>
             </a:extLst>
           </p:cNvPr>
@@ -7546,7 +7546,7 @@
           <p:nvPr/>
         </p:nvPicPr>
         <p:blipFill>
-          <a:blip xmlns:r="http://schemas.openxmlformats.org/officeDocument/2006/relationships" xmlns:a="http://schemas.openxmlformats.org/drawingml/2006/main" r:embed="Rf2b9f4056d894358"/>
+          <a:blip xmlns:r="http://schemas.openxmlformats.org/officeDocument/2006/relationships" xmlns:a="http://schemas.openxmlformats.org/drawingml/2006/main" r:embed="R0bdf2043394e4bf9"/>
           <a:stretch xmlns:a="http://schemas.openxmlformats.org/drawingml/2006/main"/>
         </p:blipFill>
         <p:spPr>
@@ -7564,7 +7564,7 @@
           <p:cNvPr id="8" name="">
             <a:extLst xmlns:a="http://schemas.openxmlformats.org/drawingml/2006/main">
               <a:ext uri="{FF2B5EF4-FFF2-40B4-BE49-F238E27FC236}">
-                <a16:creationId xmlns:a16="http://schemas.microsoft.com/office/drawing/2014/main" id="{EF311406-876A-4121-AD5B-4D3A8AC52401}"/>
+                <a16:creationId xmlns:a16="http://schemas.microsoft.com/office/drawing/2014/main" id="{14873C94-9339-4604-9D0B-621AB36E2EBF}"/>
               </a:ext>
             </a:extLst>
           </p:cNvPr>
@@ -7633,7 +7633,7 @@
           <p:cNvPr id="9" name="">
             <a:extLst xmlns:a="http://schemas.openxmlformats.org/drawingml/2006/main">
               <a:ext uri="{FF2B5EF4-FFF2-40B4-BE49-F238E27FC236}">
-                <a16:creationId xmlns:a16="http://schemas.microsoft.com/office/drawing/2014/main" id="{FD9D6DF9-B3A0-4EFF-A687-2EFC6168B6AF}"/>
+                <a16:creationId xmlns:a16="http://schemas.microsoft.com/office/drawing/2014/main" id="{BDCBA31A-7D32-40EE-B7F1-D0774E1BC2D8}"/>
               </a:ext>
             </a:extLst>
           </p:cNvPr>
@@ -7700,7 +7700,7 @@
     </p:spTree>
     <p:extLst>
       <p:ext uri="{BB962C8B-B14F-4D97-AF65-F5344CB8AC3E}">
-        <p14:creationId xmlns:p14="http://schemas.microsoft.com/office/powerpoint/2010/main" val="646973083"/>
+        <p14:creationId xmlns:p14="http://schemas.microsoft.com/office/powerpoint/2010/main" val="1989648546"/>
       </p:ext>
     </p:extLst>
   </p:cSld>
@@ -7731,7 +7731,7 @@
           <p:cNvPr id="10" name="">
             <a:extLst xmlns:a="http://schemas.openxmlformats.org/drawingml/2006/main">
               <a:ext uri="{FF2B5EF4-FFF2-40B4-BE49-F238E27FC236}">
-                <a16:creationId xmlns:a16="http://schemas.microsoft.com/office/drawing/2014/main" id="{F6515D1B-20E8-4D86-BE32-357D0B5F03CC}"/>
+                <a16:creationId xmlns:a16="http://schemas.microsoft.com/office/drawing/2014/main" id="{55103CA2-80A1-4F6F-8018-A28DD62BAAAC}"/>
               </a:ext>
             </a:extLst>
           </p:cNvPr>
@@ -7800,7 +7800,7 @@
           <p:cNvPr id="2" name="">
             <a:extLst xmlns:a="http://schemas.openxmlformats.org/drawingml/2006/main">
               <a:ext uri="{FF2B5EF4-FFF2-40B4-BE49-F238E27FC236}">
-                <a16:creationId xmlns:a16="http://schemas.microsoft.com/office/drawing/2014/main" id="{32C5BB09-2E53-4261-B27E-118701ABCD6D}"/>
+                <a16:creationId xmlns:a16="http://schemas.microsoft.com/office/drawing/2014/main" id="{5F59ED82-F304-4E8E-BD1F-5BDF59CDE650}"/>
               </a:ext>
             </a:extLst>
           </p:cNvPr>
@@ -7869,7 +7869,7 @@
           <p:cNvPr id="3" name="">
             <a:extLst xmlns:a="http://schemas.openxmlformats.org/drawingml/2006/main">
               <a:ext uri="{FF2B5EF4-FFF2-40B4-BE49-F238E27FC236}">
-                <a16:creationId xmlns:a16="http://schemas.microsoft.com/office/drawing/2014/main" id="{EF5EB0C8-D71F-48BF-AE12-825A28BADC30}"/>
+                <a16:creationId xmlns:a16="http://schemas.microsoft.com/office/drawing/2014/main" id="{47F7477B-5013-4306-8387-758B9C5C5F93}"/>
               </a:ext>
             </a:extLst>
           </p:cNvPr>
@@ -7938,7 +7938,7 @@
           <p:cNvPr id="4" name="">
             <a:extLst xmlns:a="http://schemas.openxmlformats.org/drawingml/2006/main">
               <a:ext uri="{FF2B5EF4-FFF2-40B4-BE49-F238E27FC236}">
-                <a16:creationId xmlns:a16="http://schemas.microsoft.com/office/drawing/2014/main" id="{654EE7B7-B1DD-4138-8E1D-32974AEBEFE4}"/>
+                <a16:creationId xmlns:a16="http://schemas.microsoft.com/office/drawing/2014/main" id="{A6B5CEFE-AF96-40D9-B213-651F20758E45}"/>
               </a:ext>
             </a:extLst>
           </p:cNvPr>
@@ -7997,7 +7997,7 @@
                 <a:ea typeface="Malgun Gothic"/>
                 <a:cs typeface="Malgun Gothic"/>
               </a:rPr>
-              <a:t>Python 3.12: 자동 검사 675개 통과</a:t>
+              <a:t>Python 3.12·3.13: 환경별 자동 검사 687개 통과</a:t>
             </a:r>
           </a:p>
         </p:txBody>
@@ -8007,7 +8007,7 @@
           <p:cNvPr id="5" name="">
             <a:extLst xmlns:a="http://schemas.openxmlformats.org/drawingml/2006/main">
               <a:ext uri="{FF2B5EF4-FFF2-40B4-BE49-F238E27FC236}">
-                <a16:creationId xmlns:a16="http://schemas.microsoft.com/office/drawing/2014/main" id="{08AC783D-DC93-4B3C-BF76-D2599949B048}"/>
+                <a16:creationId xmlns:a16="http://schemas.microsoft.com/office/drawing/2014/main" id="{AAB0730A-9AD1-42FA-8C20-3C71E8AD7FD9}"/>
               </a:ext>
             </a:extLst>
           </p:cNvPr>
@@ -8076,7 +8076,7 @@
           <p:cNvPr id="6" name="">
             <a:extLst xmlns:a="http://schemas.openxmlformats.org/drawingml/2006/main">
               <a:ext uri="{FF2B5EF4-FFF2-40B4-BE49-F238E27FC236}">
-                <a16:creationId xmlns:a16="http://schemas.microsoft.com/office/drawing/2014/main" id="{BE40B7E1-778A-4F0F-A3A5-57945F9B9E77}"/>
+                <a16:creationId xmlns:a16="http://schemas.microsoft.com/office/drawing/2014/main" id="{5D71C932-41DB-4113-949B-384F3372ABC8}"/>
               </a:ext>
             </a:extLst>
           </p:cNvPr>
@@ -8145,7 +8145,7 @@
           <p:cNvPr id="7" name="">
             <a:extLst xmlns:a="http://schemas.openxmlformats.org/drawingml/2006/main">
               <a:ext uri="{FF2B5EF4-FFF2-40B4-BE49-F238E27FC236}">
-                <a16:creationId xmlns:a16="http://schemas.microsoft.com/office/drawing/2014/main" id="{ECE05800-339D-4CF7-8D08-8D72EB08F81A}"/>
+                <a16:creationId xmlns:a16="http://schemas.microsoft.com/office/drawing/2014/main" id="{4FA53029-177C-4CBF-818D-F51560C0BDE7}"/>
               </a:ext>
             </a:extLst>
           </p:cNvPr>
@@ -8214,7 +8214,7 @@
           <p:cNvPr id="8" name="">
             <a:extLst xmlns:a="http://schemas.openxmlformats.org/drawingml/2006/main">
               <a:ext uri="{FF2B5EF4-FFF2-40B4-BE49-F238E27FC236}">
-                <a16:creationId xmlns:a16="http://schemas.microsoft.com/office/drawing/2014/main" id="{297199F6-30FF-466D-8342-7CD627B16C2F}"/>
+                <a16:creationId xmlns:a16="http://schemas.microsoft.com/office/drawing/2014/main" id="{8EA44A32-ECF7-4D2F-A540-26B097C7FF78}"/>
               </a:ext>
             </a:extLst>
           </p:cNvPr>
@@ -8283,7 +8283,7 @@
           <p:cNvPr id="9" name="">
             <a:extLst xmlns:a="http://schemas.openxmlformats.org/drawingml/2006/main">
               <a:ext uri="{FF2B5EF4-FFF2-40B4-BE49-F238E27FC236}">
-                <a16:creationId xmlns:a16="http://schemas.microsoft.com/office/drawing/2014/main" id="{40BBA784-599E-46EE-84FC-1D48B6F410D3}"/>
+                <a16:creationId xmlns:a16="http://schemas.microsoft.com/office/drawing/2014/main" id="{D4EFB65E-AD3E-40FA-8011-967A662F40E8}"/>
               </a:ext>
             </a:extLst>
           </p:cNvPr>
@@ -8350,7 +8350,7 @@
     </p:spTree>
     <p:extLst>
       <p:ext uri="{BB962C8B-B14F-4D97-AF65-F5344CB8AC3E}">
-        <p14:creationId xmlns:p14="http://schemas.microsoft.com/office/powerpoint/2010/main" val="559911231"/>
+        <p14:creationId xmlns:p14="http://schemas.microsoft.com/office/powerpoint/2010/main" val="117725819"/>
       </p:ext>
     </p:extLst>
   </p:cSld>
@@ -8381,7 +8381,7 @@
           <p:cNvPr id="10" name="">
             <a:extLst xmlns:a="http://schemas.openxmlformats.org/drawingml/2006/main">
               <a:ext uri="{FF2B5EF4-FFF2-40B4-BE49-F238E27FC236}">
-                <a16:creationId xmlns:a16="http://schemas.microsoft.com/office/drawing/2014/main" id="{3BF3423E-B846-4F64-9E1D-AA8F8A458418}"/>
+                <a16:creationId xmlns:a16="http://schemas.microsoft.com/office/drawing/2014/main" id="{AAA7CA3F-CEA6-41E4-98B8-64D23EAF9BFE}"/>
               </a:ext>
             </a:extLst>
           </p:cNvPr>
@@ -8450,7 +8450,7 @@
           <p:cNvPr id="2" name="">
             <a:extLst xmlns:a="http://schemas.openxmlformats.org/drawingml/2006/main">
               <a:ext uri="{FF2B5EF4-FFF2-40B4-BE49-F238E27FC236}">
-                <a16:creationId xmlns:a16="http://schemas.microsoft.com/office/drawing/2014/main" id="{D1C62C58-A70B-4676-99BB-7A95348D0C89}"/>
+                <a16:creationId xmlns:a16="http://schemas.microsoft.com/office/drawing/2014/main" id="{6A00DCB7-1ACC-4276-984F-B0600832E11A}"/>
               </a:ext>
             </a:extLst>
           </p:cNvPr>
@@ -8519,7 +8519,7 @@
           <p:cNvPr id="3" name="">
             <a:extLst xmlns:a="http://schemas.openxmlformats.org/drawingml/2006/main">
               <a:ext uri="{FF2B5EF4-FFF2-40B4-BE49-F238E27FC236}">
-                <a16:creationId xmlns:a16="http://schemas.microsoft.com/office/drawing/2014/main" id="{8CAF3851-4918-4D61-9FBD-41B692097479}"/>
+                <a16:creationId xmlns:a16="http://schemas.microsoft.com/office/drawing/2014/main" id="{FF549DCB-D47A-4B4A-9CFD-813631E9C91F}"/>
               </a:ext>
             </a:extLst>
           </p:cNvPr>
@@ -8588,7 +8588,7 @@
           <p:cNvPr id="4" name="">
             <a:extLst xmlns:a="http://schemas.openxmlformats.org/drawingml/2006/main">
               <a:ext uri="{FF2B5EF4-FFF2-40B4-BE49-F238E27FC236}">
-                <a16:creationId xmlns:a16="http://schemas.microsoft.com/office/drawing/2014/main" id="{A63BC9FD-03C3-48A9-8FA8-60494B5D7489}"/>
+                <a16:creationId xmlns:a16="http://schemas.microsoft.com/office/drawing/2014/main" id="{3B2E0893-F1E5-404B-A50B-781A52214BAA}"/>
               </a:ext>
             </a:extLst>
           </p:cNvPr>
@@ -8657,7 +8657,7 @@
           <p:cNvPr id="5" name="">
             <a:extLst xmlns:a="http://schemas.openxmlformats.org/drawingml/2006/main">
               <a:ext uri="{FF2B5EF4-FFF2-40B4-BE49-F238E27FC236}">
-                <a16:creationId xmlns:a16="http://schemas.microsoft.com/office/drawing/2014/main" id="{27C250EA-855A-48EA-B556-424C8AA22F05}"/>
+                <a16:creationId xmlns:a16="http://schemas.microsoft.com/office/drawing/2014/main" id="{2202711E-2296-4D71-94CA-BFC5EE61E73B}"/>
               </a:ext>
             </a:extLst>
           </p:cNvPr>
@@ -8726,7 +8726,7 @@
           <p:cNvPr id="6" name="">
             <a:extLst xmlns:a="http://schemas.openxmlformats.org/drawingml/2006/main">
               <a:ext uri="{FF2B5EF4-FFF2-40B4-BE49-F238E27FC236}">
-                <a16:creationId xmlns:a16="http://schemas.microsoft.com/office/drawing/2014/main" id="{EEC31B4C-1286-4F91-905B-A964A9E7EFD9}"/>
+                <a16:creationId xmlns:a16="http://schemas.microsoft.com/office/drawing/2014/main" id="{EF058745-E4DF-47FF-9672-0A6DCC03DEE3}"/>
               </a:ext>
             </a:extLst>
           </p:cNvPr>
@@ -8795,7 +8795,7 @@
           <p:cNvPr id="7" name="">
             <a:extLst xmlns:a="http://schemas.openxmlformats.org/drawingml/2006/main">
               <a:ext uri="{FF2B5EF4-FFF2-40B4-BE49-F238E27FC236}">
-                <a16:creationId xmlns:a16="http://schemas.microsoft.com/office/drawing/2014/main" id="{7D0854CB-08C0-4E48-80A3-131A6FBD9451}"/>
+                <a16:creationId xmlns:a16="http://schemas.microsoft.com/office/drawing/2014/main" id="{EB33C7D0-DBDA-435D-AFC8-2DBB5ACC5C37}"/>
               </a:ext>
             </a:extLst>
           </p:cNvPr>
@@ -8864,7 +8864,7 @@
           <p:cNvPr id="8" name="">
             <a:extLst xmlns:a="http://schemas.openxmlformats.org/drawingml/2006/main">
               <a:ext uri="{FF2B5EF4-FFF2-40B4-BE49-F238E27FC236}">
-                <a16:creationId xmlns:a16="http://schemas.microsoft.com/office/drawing/2014/main" id="{0BC21A80-6D4C-4481-BF82-361C8DAB4F0A}"/>
+                <a16:creationId xmlns:a16="http://schemas.microsoft.com/office/drawing/2014/main" id="{F355967E-7D00-4D75-AB3C-382F028A3B79}"/>
               </a:ext>
             </a:extLst>
           </p:cNvPr>
@@ -8933,7 +8933,7 @@
           <p:cNvPr id="9" name="">
             <a:extLst xmlns:a="http://schemas.openxmlformats.org/drawingml/2006/main">
               <a:ext uri="{FF2B5EF4-FFF2-40B4-BE49-F238E27FC236}">
-                <a16:creationId xmlns:a16="http://schemas.microsoft.com/office/drawing/2014/main" id="{B7CCCAFF-AADA-4F33-AA83-DCAC415D3345}"/>
+                <a16:creationId xmlns:a16="http://schemas.microsoft.com/office/drawing/2014/main" id="{8BE306D3-6F9B-46B4-9520-316EB6D4A1C0}"/>
               </a:ext>
             </a:extLst>
           </p:cNvPr>
@@ -9000,7 +9000,7 @@
     </p:spTree>
     <p:extLst>
       <p:ext uri="{BB962C8B-B14F-4D97-AF65-F5344CB8AC3E}">
-        <p14:creationId xmlns:p14="http://schemas.microsoft.com/office/powerpoint/2010/main" val="759475028"/>
+        <p14:creationId xmlns:p14="http://schemas.microsoft.com/office/powerpoint/2010/main" val="468537044"/>
       </p:ext>
     </p:extLst>
   </p:cSld>
@@ -9031,7 +9031,7 @@
           <p:cNvPr id="10" name="">
             <a:extLst xmlns:a="http://schemas.openxmlformats.org/drawingml/2006/main">
               <a:ext uri="{FF2B5EF4-FFF2-40B4-BE49-F238E27FC236}">
-                <a16:creationId xmlns:a16="http://schemas.microsoft.com/office/drawing/2014/main" id="{FB0D6527-BD94-4806-95AC-D722A695F95F}"/>
+                <a16:creationId xmlns:a16="http://schemas.microsoft.com/office/drawing/2014/main" id="{52E00B66-A492-4725-B59A-867155B1C8B6}"/>
               </a:ext>
             </a:extLst>
           </p:cNvPr>
@@ -9100,7 +9100,7 @@
           <p:cNvPr id="2" name="">
             <a:extLst xmlns:a="http://schemas.openxmlformats.org/drawingml/2006/main">
               <a:ext uri="{FF2B5EF4-FFF2-40B4-BE49-F238E27FC236}">
-                <a16:creationId xmlns:a16="http://schemas.microsoft.com/office/drawing/2014/main" id="{CC2F3597-A63B-46F0-B2BB-CD09305EECCD}"/>
+                <a16:creationId xmlns:a16="http://schemas.microsoft.com/office/drawing/2014/main" id="{7124A33D-7935-4C60-B03D-CFA74DAE0CD0}"/>
               </a:ext>
             </a:extLst>
           </p:cNvPr>
@@ -9169,7 +9169,7 @@
           <p:cNvPr id="3" name="">
             <a:extLst xmlns:a="http://schemas.openxmlformats.org/drawingml/2006/main">
               <a:ext uri="{FF2B5EF4-FFF2-40B4-BE49-F238E27FC236}">
-                <a16:creationId xmlns:a16="http://schemas.microsoft.com/office/drawing/2014/main" id="{46916A90-CCFF-4C3A-B59B-21D090800FBB}"/>
+                <a16:creationId xmlns:a16="http://schemas.microsoft.com/office/drawing/2014/main" id="{A552B9EB-60C8-422E-B93C-0423FA0DB8D7}"/>
               </a:ext>
             </a:extLst>
           </p:cNvPr>
@@ -9238,7 +9238,7 @@
           <p:cNvPr id="4" name="">
             <a:extLst xmlns:a="http://schemas.openxmlformats.org/drawingml/2006/main">
               <a:ext uri="{FF2B5EF4-FFF2-40B4-BE49-F238E27FC236}">
-                <a16:creationId xmlns:a16="http://schemas.microsoft.com/office/drawing/2014/main" id="{914A79AC-169C-4143-94C0-3B2412C5255F}"/>
+                <a16:creationId xmlns:a16="http://schemas.microsoft.com/office/drawing/2014/main" id="{EA49200D-1E1D-4B1A-94BE-73C88651BC1D}"/>
               </a:ext>
             </a:extLst>
           </p:cNvPr>
@@ -9307,7 +9307,7 @@
           <p:cNvPr id="5" name="">
             <a:extLst xmlns:a="http://schemas.openxmlformats.org/drawingml/2006/main">
               <a:ext uri="{FF2B5EF4-FFF2-40B4-BE49-F238E27FC236}">
-                <a16:creationId xmlns:a16="http://schemas.microsoft.com/office/drawing/2014/main" id="{C0A97871-5DDE-4866-8E33-C2F7ABE152EA}"/>
+                <a16:creationId xmlns:a16="http://schemas.microsoft.com/office/drawing/2014/main" id="{090BF863-7F24-4587-AC47-15757F908368}"/>
               </a:ext>
             </a:extLst>
           </p:cNvPr>
@@ -9376,7 +9376,7 @@
           <p:cNvPr id="6" name="">
             <a:extLst xmlns:a="http://schemas.openxmlformats.org/drawingml/2006/main">
               <a:ext uri="{FF2B5EF4-FFF2-40B4-BE49-F238E27FC236}">
-                <a16:creationId xmlns:a16="http://schemas.microsoft.com/office/drawing/2014/main" id="{EA3F4416-1A8D-4F33-B318-F1F66342281B}"/>
+                <a16:creationId xmlns:a16="http://schemas.microsoft.com/office/drawing/2014/main" id="{16AB3ACD-DC6B-47FB-8C3C-41D09425ACBC}"/>
               </a:ext>
             </a:extLst>
           </p:cNvPr>
@@ -9445,7 +9445,7 @@
           <p:cNvPr id="7" name="">
             <a:extLst xmlns:a="http://schemas.openxmlformats.org/drawingml/2006/main">
               <a:ext uri="{FF2B5EF4-FFF2-40B4-BE49-F238E27FC236}">
-                <a16:creationId xmlns:a16="http://schemas.microsoft.com/office/drawing/2014/main" id="{81B85065-4CFF-48BE-984D-1B8DE1913716}"/>
+                <a16:creationId xmlns:a16="http://schemas.microsoft.com/office/drawing/2014/main" id="{B29C5C57-178D-455A-B476-7558696BE2C4}"/>
               </a:ext>
             </a:extLst>
           </p:cNvPr>
@@ -9504,7 +9504,7 @@
                 <a:ea typeface="Malgun Gothic"/>
                 <a:cs typeface="Malgun Gothic"/>
               </a:rPr>
-              <a:t>일반 역사 원문 검색 확대와 최종 팀 검토·제출</a:t>
+              <a:t>한국사 외 자료·본문 학습 확대와 최종 팀 검토·제출</a:t>
             </a:r>
           </a:p>
         </p:txBody>
@@ -9514,7 +9514,7 @@
           <p:cNvPr id="8" name="">
             <a:extLst xmlns:a="http://schemas.openxmlformats.org/drawingml/2006/main">
               <a:ext uri="{FF2B5EF4-FFF2-40B4-BE49-F238E27FC236}">
-                <a16:creationId xmlns:a16="http://schemas.microsoft.com/office/drawing/2014/main" id="{87C5E58A-F9FE-49A4-BC50-8FDB168C11EB}"/>
+                <a16:creationId xmlns:a16="http://schemas.microsoft.com/office/drawing/2014/main" id="{C4F0D27A-5964-4AE7-84C0-9BAA9D97727D}"/>
               </a:ext>
             </a:extLst>
           </p:cNvPr>
@@ -9583,7 +9583,7 @@
           <p:cNvPr id="9" name="">
             <a:extLst xmlns:a="http://schemas.openxmlformats.org/drawingml/2006/main">
               <a:ext uri="{FF2B5EF4-FFF2-40B4-BE49-F238E27FC236}">
-                <a16:creationId xmlns:a16="http://schemas.microsoft.com/office/drawing/2014/main" id="{0074CE4D-9117-4C49-9BF2-F34E038EF9DB}"/>
+                <a16:creationId xmlns:a16="http://schemas.microsoft.com/office/drawing/2014/main" id="{41EDE2FD-CBB2-4770-B0CD-C28ED0F5CB71}"/>
               </a:ext>
             </a:extLst>
           </p:cNvPr>
@@ -9650,7 +9650,7 @@
     </p:spTree>
     <p:extLst>
       <p:ext uri="{BB962C8B-B14F-4D97-AF65-F5344CB8AC3E}">
-        <p14:creationId xmlns:p14="http://schemas.microsoft.com/office/powerpoint/2010/main" val="242115588"/>
+        <p14:creationId xmlns:p14="http://schemas.microsoft.com/office/powerpoint/2010/main" val="580516220"/>
       </p:ext>
     </p:extLst>
   </p:cSld>

</xml_diff>